<commit_message>
Update group presentation slides
</commit_message>
<xml_diff>
--- a/presentation/AT3_Slide_Group_2.pptx
+++ b/presentation/AT3_Slide_Group_2.pptx
@@ -16666,7 +16666,7 @@
         </p:nvSpPr>
         <p:spPr>
           <a:xfrm>
-            <a:off x="1371600" y="960120"/>
+            <a:off x="1371600" y="1713559"/>
             <a:ext cx="6400800" cy="914400"/>
           </a:xfrm>
           <a:prstGeom prst="rect">
@@ -16705,7 +16705,7 @@
         </p:nvSpPr>
         <p:spPr>
           <a:xfrm>
-            <a:off x="3474720" y="1938528"/>
+            <a:off x="3474720" y="2691967"/>
             <a:ext cx="2194560" cy="45720"/>
           </a:xfrm>
           <a:prstGeom prst="rect">
@@ -16737,7 +16737,7 @@
         </p:nvSpPr>
         <p:spPr>
           <a:xfrm>
-            <a:off x="1371600" y="2103120"/>
+            <a:off x="1371600" y="2856559"/>
             <a:ext cx="6400800" cy="502920"/>
           </a:xfrm>
           <a:prstGeom prst="rect">
@@ -16765,432 +16765,6 @@
               <a:t>Questions &amp; Discussion</a:t>
             </a:r>
             <a:endParaRPr lang="en-US" sz="2200" dirty="0"/>
-          </a:p>
-        </p:txBody>
-      </p:sp>
-      <p:sp>
-        <p:nvSpPr>
-          <p:cNvPr id="32" name="Shape 6"/>
-          <p:cNvSpPr/>
-          <p:nvPr/>
-        </p:nvSpPr>
-        <p:spPr>
-          <a:xfrm>
-            <a:off x="1508760" y="2743200"/>
-            <a:ext cx="1920240" cy="1554480"/>
-          </a:xfrm>
-          <a:prstGeom prst="rect">
-            <a:avLst/>
-          </a:prstGeom>
-          <a:solidFill>
-            <a:srgbClr val="1A2F4A"/>
-          </a:solidFill>
-          <a:ln w="6350">
-            <a:solidFill>
-              <a:srgbClr val="1E3A5F"/>
-            </a:solidFill>
-            <a:prstDash val="solid"/>
-          </a:ln>
-        </p:spPr>
-        <p:txBody>
-          <a:bodyPr/>
-          <a:lstStyle/>
-          <a:p>
-            <a:endParaRPr lang="en-AU"/>
-          </a:p>
-        </p:txBody>
-      </p:sp>
-      <p:sp>
-        <p:nvSpPr>
-          <p:cNvPr id="33" name="Shape 7"/>
-          <p:cNvSpPr/>
-          <p:nvPr/>
-        </p:nvSpPr>
-        <p:spPr>
-          <a:xfrm>
-            <a:off x="1508760" y="2743200"/>
-            <a:ext cx="1920240" cy="54864"/>
-          </a:xfrm>
-          <a:prstGeom prst="rect">
-            <a:avLst/>
-          </a:prstGeom>
-          <a:solidFill>
-            <a:srgbClr val="00C9B8"/>
-          </a:solidFill>
-          <a:ln w="12700">
-            <a:solidFill>
-              <a:srgbClr val="000000"/>
-            </a:solidFill>
-            <a:prstDash val="solid"/>
-          </a:ln>
-        </p:spPr>
-        <p:txBody>
-          <a:bodyPr/>
-          <a:lstStyle/>
-          <a:p>
-            <a:endParaRPr lang="en-AU"/>
-          </a:p>
-        </p:txBody>
-      </p:sp>
-      <p:sp>
-        <p:nvSpPr>
-          <p:cNvPr id="34" name="Text 8"/>
-          <p:cNvSpPr/>
-          <p:nvPr/>
-        </p:nvSpPr>
-        <p:spPr>
-          <a:xfrm>
-            <a:off x="1600200" y="2834640"/>
-            <a:ext cx="1737360" cy="347472"/>
-          </a:xfrm>
-          <a:prstGeom prst="rect">
-            <a:avLst/>
-          </a:prstGeom>
-          <a:noFill/>
-          <a:ln/>
-        </p:spPr>
-        <p:txBody>
-          <a:bodyPr wrap="square" lIns="0" tIns="0" rIns="0" bIns="0" rtlCol="0" anchor="ctr"/>
-          <a:lstStyle/>
-          <a:p>
-            <a:pPr marL="0" indent="0">
-              <a:buNone/>
-            </a:pPr>
-            <a:r>
-              <a:rPr lang="en-US" sz="900" b="1" dirty="0">
-                <a:solidFill>
-                  <a:srgbClr val="FFFFFF"/>
-                </a:solidFill>
-                <a:latin typeface="Trebuchet MS" pitchFamily="34" charset="0"/>
-                <a:ea typeface="Trebuchet MS" pitchFamily="34" charset="-122"/>
-                <a:cs typeface="Trebuchet MS" pitchFamily="34" charset="-120"/>
-              </a:rPr>
-              <a:t>Why Linear SVM?</a:t>
-            </a:r>
-            <a:endParaRPr lang="en-US" sz="900" dirty="0"/>
-          </a:p>
-        </p:txBody>
-      </p:sp>
-      <p:sp>
-        <p:nvSpPr>
-          <p:cNvPr id="35" name="Text 9"/>
-          <p:cNvSpPr/>
-          <p:nvPr/>
-        </p:nvSpPr>
-        <p:spPr>
-          <a:xfrm>
-            <a:off x="1600200" y="3200400"/>
-            <a:ext cx="1737360" cy="749808"/>
-          </a:xfrm>
-          <a:prstGeom prst="rect">
-            <a:avLst/>
-          </a:prstGeom>
-          <a:noFill/>
-          <a:ln/>
-        </p:spPr>
-        <p:txBody>
-          <a:bodyPr wrap="square" lIns="0" tIns="0" rIns="0" bIns="0" rtlCol="0" anchor="ctr"/>
-          <a:lstStyle/>
-          <a:p>
-            <a:pPr marL="0" indent="0">
-              <a:buNone/>
-            </a:pPr>
-            <a:r>
-              <a:rPr lang="en-US" sz="850" dirty="0">
-                <a:solidFill>
-                  <a:srgbClr val="A8C4D8"/>
-                </a:solidFill>
-                <a:latin typeface="Trebuchet MS" pitchFamily="34" charset="0"/>
-                <a:ea typeface="Trebuchet MS" pitchFamily="34" charset="-122"/>
-                <a:cs typeface="Trebuchet MS" pitchFamily="34" charset="-120"/>
-              </a:rPr>
-              <a:t>Best macro F1 on validation; handles sparse TF-IDF features well</a:t>
-            </a:r>
-            <a:endParaRPr lang="en-US" sz="850" dirty="0"/>
-          </a:p>
-        </p:txBody>
-      </p:sp>
-      <p:sp>
-        <p:nvSpPr>
-          <p:cNvPr id="36" name="Shape 10"/>
-          <p:cNvSpPr/>
-          <p:nvPr/>
-        </p:nvSpPr>
-        <p:spPr>
-          <a:xfrm>
-            <a:off x="3630168" y="2743200"/>
-            <a:ext cx="1920240" cy="1554480"/>
-          </a:xfrm>
-          <a:prstGeom prst="rect">
-            <a:avLst/>
-          </a:prstGeom>
-          <a:solidFill>
-            <a:srgbClr val="1A2F4A"/>
-          </a:solidFill>
-          <a:ln w="6350">
-            <a:solidFill>
-              <a:srgbClr val="1E3A5F"/>
-            </a:solidFill>
-            <a:prstDash val="solid"/>
-          </a:ln>
-        </p:spPr>
-        <p:txBody>
-          <a:bodyPr/>
-          <a:lstStyle/>
-          <a:p>
-            <a:endParaRPr lang="en-AU"/>
-          </a:p>
-        </p:txBody>
-      </p:sp>
-      <p:sp>
-        <p:nvSpPr>
-          <p:cNvPr id="37" name="Shape 11"/>
-          <p:cNvSpPr/>
-          <p:nvPr/>
-        </p:nvSpPr>
-        <p:spPr>
-          <a:xfrm>
-            <a:off x="3630168" y="2743200"/>
-            <a:ext cx="1920240" cy="54864"/>
-          </a:xfrm>
-          <a:prstGeom prst="rect">
-            <a:avLst/>
-          </a:prstGeom>
-          <a:solidFill>
-            <a:srgbClr val="FF6B6B"/>
-          </a:solidFill>
-          <a:ln w="12700">
-            <a:solidFill>
-              <a:srgbClr val="000000"/>
-            </a:solidFill>
-            <a:prstDash val="solid"/>
-          </a:ln>
-        </p:spPr>
-        <p:txBody>
-          <a:bodyPr/>
-          <a:lstStyle/>
-          <a:p>
-            <a:endParaRPr lang="en-AU"/>
-          </a:p>
-        </p:txBody>
-      </p:sp>
-      <p:sp>
-        <p:nvSpPr>
-          <p:cNvPr id="38" name="Text 12"/>
-          <p:cNvSpPr/>
-          <p:nvPr/>
-        </p:nvSpPr>
-        <p:spPr>
-          <a:xfrm>
-            <a:off x="3721608" y="2834640"/>
-            <a:ext cx="1737360" cy="347472"/>
-          </a:xfrm>
-          <a:prstGeom prst="rect">
-            <a:avLst/>
-          </a:prstGeom>
-          <a:noFill/>
-          <a:ln/>
-        </p:spPr>
-        <p:txBody>
-          <a:bodyPr wrap="square" lIns="0" tIns="0" rIns="0" bIns="0" rtlCol="0" anchor="ctr"/>
-          <a:lstStyle/>
-          <a:p>
-            <a:pPr marL="0" indent="0">
-              <a:buNone/>
-            </a:pPr>
-            <a:r>
-              <a:rPr lang="en-US" sz="900" b="1" dirty="0">
-                <a:solidFill>
-                  <a:srgbClr val="FFFFFF"/>
-                </a:solidFill>
-                <a:latin typeface="Trebuchet MS" pitchFamily="34" charset="0"/>
-                <a:ea typeface="Trebuchet MS" pitchFamily="34" charset="-122"/>
-                <a:cs typeface="Trebuchet MS" pitchFamily="34" charset="-120"/>
-              </a:rPr>
-              <a:t>Why moderate F1?</a:t>
-            </a:r>
-            <a:endParaRPr lang="en-US" sz="900" dirty="0"/>
-          </a:p>
-        </p:txBody>
-      </p:sp>
-      <p:sp>
-        <p:nvSpPr>
-          <p:cNvPr id="39" name="Text 13"/>
-          <p:cNvSpPr/>
-          <p:nvPr/>
-        </p:nvSpPr>
-        <p:spPr>
-          <a:xfrm>
-            <a:off x="3721608" y="3200400"/>
-            <a:ext cx="1737360" cy="749808"/>
-          </a:xfrm>
-          <a:prstGeom prst="rect">
-            <a:avLst/>
-          </a:prstGeom>
-          <a:noFill/>
-          <a:ln/>
-        </p:spPr>
-        <p:txBody>
-          <a:bodyPr wrap="square" lIns="0" tIns="0" rIns="0" bIns="0" rtlCol="0" anchor="ctr"/>
-          <a:lstStyle/>
-          <a:p>
-            <a:pPr marL="0" indent="0">
-              <a:buNone/>
-            </a:pPr>
-            <a:r>
-              <a:rPr lang="en-US" sz="850" dirty="0">
-                <a:solidFill>
-                  <a:srgbClr val="A8C4D8"/>
-                </a:solidFill>
-                <a:latin typeface="Trebuchet MS" pitchFamily="34" charset="0"/>
-                <a:ea typeface="Trebuchet MS" pitchFamily="34" charset="-122"/>
-                <a:cs typeface="Trebuchet MS" pitchFamily="34" charset="-120"/>
-              </a:rPr>
-              <a:t>Overlapping categories + multilingual imbalance — supports human-in-the-loop design</a:t>
-            </a:r>
-            <a:endParaRPr lang="en-US" sz="850" dirty="0"/>
-          </a:p>
-        </p:txBody>
-      </p:sp>
-      <p:sp>
-        <p:nvSpPr>
-          <p:cNvPr id="40" name="Shape 14"/>
-          <p:cNvSpPr/>
-          <p:nvPr/>
-        </p:nvSpPr>
-        <p:spPr>
-          <a:xfrm>
-            <a:off x="5751576" y="2743200"/>
-            <a:ext cx="1920240" cy="1554480"/>
-          </a:xfrm>
-          <a:prstGeom prst="rect">
-            <a:avLst/>
-          </a:prstGeom>
-          <a:solidFill>
-            <a:srgbClr val="1A2F4A"/>
-          </a:solidFill>
-          <a:ln w="6350">
-            <a:solidFill>
-              <a:srgbClr val="1E3A5F"/>
-            </a:solidFill>
-            <a:prstDash val="solid"/>
-          </a:ln>
-        </p:spPr>
-        <p:txBody>
-          <a:bodyPr/>
-          <a:lstStyle/>
-          <a:p>
-            <a:endParaRPr lang="en-AU"/>
-          </a:p>
-        </p:txBody>
-      </p:sp>
-      <p:sp>
-        <p:nvSpPr>
-          <p:cNvPr id="41" name="Shape 15"/>
-          <p:cNvSpPr/>
-          <p:nvPr/>
-        </p:nvSpPr>
-        <p:spPr>
-          <a:xfrm>
-            <a:off x="5751576" y="2743200"/>
-            <a:ext cx="1920240" cy="54864"/>
-          </a:xfrm>
-          <a:prstGeom prst="rect">
-            <a:avLst/>
-          </a:prstGeom>
-          <a:solidFill>
-            <a:srgbClr val="F5C842"/>
-          </a:solidFill>
-          <a:ln w="12700">
-            <a:solidFill>
-              <a:srgbClr val="000000"/>
-            </a:solidFill>
-            <a:prstDash val="solid"/>
-          </a:ln>
-        </p:spPr>
-        <p:txBody>
-          <a:bodyPr/>
-          <a:lstStyle/>
-          <a:p>
-            <a:endParaRPr lang="en-AU"/>
-          </a:p>
-        </p:txBody>
-      </p:sp>
-      <p:sp>
-        <p:nvSpPr>
-          <p:cNvPr id="42" name="Text 16"/>
-          <p:cNvSpPr/>
-          <p:nvPr/>
-        </p:nvSpPr>
-        <p:spPr>
-          <a:xfrm>
-            <a:off x="5843016" y="2834640"/>
-            <a:ext cx="1737360" cy="347472"/>
-          </a:xfrm>
-          <a:prstGeom prst="rect">
-            <a:avLst/>
-          </a:prstGeom>
-          <a:noFill/>
-          <a:ln/>
-        </p:spPr>
-        <p:txBody>
-          <a:bodyPr wrap="square" lIns="0" tIns="0" rIns="0" bIns="0" rtlCol="0" anchor="ctr"/>
-          <a:lstStyle/>
-          <a:p>
-            <a:pPr marL="0" indent="0">
-              <a:buNone/>
-            </a:pPr>
-            <a:r>
-              <a:rPr lang="en-US" sz="900" b="1" dirty="0">
-                <a:solidFill>
-                  <a:srgbClr val="FFFFFF"/>
-                </a:solidFill>
-                <a:latin typeface="Trebuchet MS" pitchFamily="34" charset="0"/>
-                <a:ea typeface="Trebuchet MS" pitchFamily="34" charset="-122"/>
-                <a:cs typeface="Trebuchet MS" pitchFamily="34" charset="-120"/>
-              </a:rPr>
-              <a:t>What makes it responsible?</a:t>
-            </a:r>
-            <a:endParaRPr lang="en-US" sz="900" dirty="0"/>
-          </a:p>
-        </p:txBody>
-      </p:sp>
-      <p:sp>
-        <p:nvSpPr>
-          <p:cNvPr id="43" name="Text 17"/>
-          <p:cNvSpPr/>
-          <p:nvPr/>
-        </p:nvSpPr>
-        <p:spPr>
-          <a:xfrm>
-            <a:off x="5843016" y="3200400"/>
-            <a:ext cx="1737360" cy="749808"/>
-          </a:xfrm>
-          <a:prstGeom prst="rect">
-            <a:avLst/>
-          </a:prstGeom>
-          <a:noFill/>
-          <a:ln/>
-        </p:spPr>
-        <p:txBody>
-          <a:bodyPr wrap="square" lIns="0" tIns="0" rIns="0" bIns="0" rtlCol="0" anchor="ctr"/>
-          <a:lstStyle/>
-          <a:p>
-            <a:pPr marL="0" indent="0">
-              <a:buNone/>
-            </a:pPr>
-            <a:r>
-              <a:rPr lang="en-US" sz="850" dirty="0">
-                <a:solidFill>
-                  <a:srgbClr val="A8C4D8"/>
-                </a:solidFill>
-                <a:latin typeface="Trebuchet MS" pitchFamily="34" charset="0"/>
-                <a:ea typeface="Trebuchet MS" pitchFamily="34" charset="-122"/>
-                <a:cs typeface="Trebuchet MS" pitchFamily="34" charset="-120"/>
-              </a:rPr>
-              <a:t>Leakage control, privacy masking, explanation terms, escalation rules, human oversight</a:t>
-            </a:r>
-            <a:endParaRPr lang="en-US" sz="850" dirty="0"/>
           </a:p>
         </p:txBody>
       </p:sp>

</xml_diff>